<commit_message>
remove a test project
</commit_message>
<xml_diff>
--- a/Files/Wael_Elqamash - AI_Upskill - July.2026.pptx
+++ b/Files/Wael_Elqamash - AI_Upskill - July.2026.pptx
@@ -115,7 +115,7 @@
 <file path=ppt/revisionInfo.xml><?xml version="1.0" encoding="utf-8"?>
 <p1510:revInfo xmlns:a="http://schemas.openxmlformats.org/drawingml/2006/main" xmlns:r="http://schemas.openxmlformats.org/officeDocument/2006/relationships" xmlns:p1510="http://schemas.microsoft.com/office/powerpoint/2015/10/main">
   <p1510:revLst>
-    <p1510:client id="{2364F21E-026A-45B9-8D54-95CAB631EA77}" v="9" dt="2026-07-15T15:28:50.759"/>
+    <p1510:client id="{2364F21E-026A-45B9-8D54-95CAB631EA77}" v="10" dt="2026-07-16T08:53:55.383"/>
   </p1510:revLst>
 </p1510:revInfo>
 </file>
@@ -125,12 +125,12 @@
   <pc:docChgLst>
     <pc:chgData name="Wael El-Qamash" userId="dcf6721a-495b-4910-9497-6e783eafd4a4" providerId="ADAL" clId="{77E9CEDD-FC04-478F-B5E0-81F94C89178F}"/>
     <pc:docChg chg="undo custSel modSld">
-      <pc:chgData name="Wael El-Qamash" userId="dcf6721a-495b-4910-9497-6e783eafd4a4" providerId="ADAL" clId="{77E9CEDD-FC04-478F-B5E0-81F94C89178F}" dt="2026-07-16T08:26:16.117" v="789" actId="20577"/>
+      <pc:chgData name="Wael El-Qamash" userId="dcf6721a-495b-4910-9497-6e783eafd4a4" providerId="ADAL" clId="{77E9CEDD-FC04-478F-B5E0-81F94C89178F}" dt="2026-07-16T08:53:55.383" v="847"/>
       <pc:docMkLst>
         <pc:docMk/>
       </pc:docMkLst>
       <pc:sldChg chg="addSp delSp modSp mod">
-        <pc:chgData name="Wael El-Qamash" userId="dcf6721a-495b-4910-9497-6e783eafd4a4" providerId="ADAL" clId="{77E9CEDD-FC04-478F-B5E0-81F94C89178F}" dt="2026-07-16T08:26:16.117" v="789" actId="20577"/>
+        <pc:chgData name="Wael El-Qamash" userId="dcf6721a-495b-4910-9497-6e783eafd4a4" providerId="ADAL" clId="{77E9CEDD-FC04-478F-B5E0-81F94C89178F}" dt="2026-07-16T08:53:55.383" v="847"/>
         <pc:sldMkLst>
           <pc:docMk/>
           <pc:sldMk cId="0" sldId="256"/>
@@ -232,6 +232,14 @@
           </ac:spMkLst>
         </pc:spChg>
         <pc:spChg chg="mod">
+          <ac:chgData name="Wael El-Qamash" userId="dcf6721a-495b-4910-9497-6e783eafd4a4" providerId="ADAL" clId="{77E9CEDD-FC04-478F-B5E0-81F94C89178F}" dt="2026-07-16T08:53:52.282" v="846" actId="1076"/>
+          <ac:spMkLst>
+            <pc:docMk/>
+            <pc:sldMk cId="0" sldId="256"/>
+            <ac:spMk id="67" creationId="{00000000-0000-0000-0000-000000000000}"/>
+          </ac:spMkLst>
+        </pc:spChg>
+        <pc:spChg chg="mod">
           <ac:chgData name="Wael El-Qamash" userId="dcf6721a-495b-4910-9497-6e783eafd4a4" providerId="ADAL" clId="{77E9CEDD-FC04-478F-B5E0-81F94C89178F}" dt="2026-07-16T08:15:44.787" v="617" actId="20577"/>
           <ac:spMkLst>
             <pc:docMk/>
@@ -240,7 +248,7 @@
           </ac:spMkLst>
         </pc:spChg>
         <pc:spChg chg="mod">
-          <ac:chgData name="Wael El-Qamash" userId="dcf6721a-495b-4910-9497-6e783eafd4a4" providerId="ADAL" clId="{77E9CEDD-FC04-478F-B5E0-81F94C89178F}" dt="2026-07-16T08:25:06.704" v="681" actId="20577"/>
+          <ac:chgData name="Wael El-Qamash" userId="dcf6721a-495b-4910-9497-6e783eafd4a4" providerId="ADAL" clId="{77E9CEDD-FC04-478F-B5E0-81F94C89178F}" dt="2026-07-16T08:53:00.987" v="843" actId="20577"/>
           <ac:spMkLst>
             <pc:docMk/>
             <pc:sldMk cId="0" sldId="256"/>
@@ -253,6 +261,14 @@
             <pc:docMk/>
             <pc:sldMk cId="0" sldId="256"/>
             <ac:spMk id="80" creationId="{00000000-0000-0000-0000-000000000000}"/>
+          </ac:spMkLst>
+        </pc:spChg>
+        <pc:spChg chg="mod">
+          <ac:chgData name="Wael El-Qamash" userId="dcf6721a-495b-4910-9497-6e783eafd4a4" providerId="ADAL" clId="{77E9CEDD-FC04-478F-B5E0-81F94C89178F}" dt="2026-07-16T08:53:55.383" v="847"/>
+          <ac:spMkLst>
+            <pc:docMk/>
+            <pc:sldMk cId="0" sldId="256"/>
+            <ac:spMk id="83" creationId="{00000000-0000-0000-0000-000000000000}"/>
           </ac:spMkLst>
         </pc:spChg>
         <pc:spChg chg="mod">
@@ -3476,7 +3492,7 @@
                   <a:srgbClr val="A8BFDA"/>
                 </a:solidFill>
               </a:rPr>
-              <a:t>I learned using </a:t>
+              <a:t>I learned using SDD with </a:t>
             </a:r>
             <a:r>
               <a:rPr lang="en-US" sz="850" dirty="0" err="1">
@@ -3486,128 +3502,15 @@
               </a:rPr>
               <a:t>SpecKit</a:t>
             </a:r>
-            <a:endParaRPr lang="en-US" sz="850" dirty="0"/>
-          </a:p>
-        </p:txBody>
-      </p:sp>
-      <p:sp>
-        <p:nvSpPr>
-          <p:cNvPr id="77" name="Shape 75"/>
-          <p:cNvSpPr/>
-          <p:nvPr/>
-        </p:nvSpPr>
-        <p:spPr>
-          <a:xfrm>
-            <a:off x="8677656" y="4160520"/>
-            <a:ext cx="3182112" cy="0"/>
-          </a:xfrm>
-          <a:prstGeom prst="line">
-            <a:avLst/>
-          </a:prstGeom>
-          <a:noFill/>
-          <a:ln w="5080">
-            <a:solidFill>
-              <a:srgbClr val="132238"/>
-            </a:solidFill>
-            <a:prstDash val="solid"/>
-          </a:ln>
-        </p:spPr>
-        <p:txBody>
-          <a:bodyPr/>
-          <a:lstStyle/>
-          <a:p>
-            <a:endParaRPr lang="en-US"/>
-          </a:p>
-        </p:txBody>
-      </p:sp>
-      <p:sp>
-        <p:nvSpPr>
-          <p:cNvPr id="78" name="Shape 76"/>
-          <p:cNvSpPr/>
-          <p:nvPr/>
-        </p:nvSpPr>
-        <p:spPr>
-          <a:xfrm>
-            <a:off x="8677656" y="4251960"/>
-            <a:ext cx="36576" cy="1143000"/>
-          </a:xfrm>
-          <a:prstGeom prst="rect">
-            <a:avLst/>
-          </a:prstGeom>
-          <a:solidFill>
-            <a:srgbClr val="00C8E0"/>
-          </a:solidFill>
-          <a:ln w="12700">
-            <a:solidFill>
-              <a:srgbClr val="00C8E0"/>
-            </a:solidFill>
-            <a:prstDash val="solid"/>
-          </a:ln>
-        </p:spPr>
-        <p:txBody>
-          <a:bodyPr/>
-          <a:lstStyle/>
-          <a:p>
-            <a:endParaRPr lang="en-US"/>
-          </a:p>
-        </p:txBody>
-      </p:sp>
-      <p:sp>
-        <p:nvSpPr>
-          <p:cNvPr id="79" name="Text 77"/>
-          <p:cNvSpPr/>
-          <p:nvPr/>
-        </p:nvSpPr>
-        <p:spPr>
-          <a:xfrm>
-            <a:off x="8796528" y="4343400"/>
-            <a:ext cx="3044952" cy="201168"/>
-          </a:xfrm>
-          <a:prstGeom prst="rect">
-            <a:avLst/>
-          </a:prstGeom>
-          <a:noFill/>
-          <a:ln/>
-        </p:spPr>
-        <p:txBody>
-          <a:bodyPr wrap="square" lIns="0" tIns="0" rIns="0" bIns="0" rtlCol="0" anchor="ctr"/>
-          <a:lstStyle/>
-          <a:p>
-            <a:pPr marL="0" indent="0">
-              <a:buNone/>
-            </a:pPr>
-            <a:r>
-              <a:rPr lang="en-US" sz="750" b="1" kern="0" spc="200" dirty="0">
-                <a:solidFill>
-                  <a:srgbClr val="4A6380"/>
-                </a:solidFill>
-              </a:rPr>
-              <a:t>NEXT STEPS</a:t>
-            </a:r>
-            <a:endParaRPr lang="en-US" sz="750" dirty="0"/>
-          </a:p>
-        </p:txBody>
-      </p:sp>
-      <p:sp>
-        <p:nvSpPr>
-          <p:cNvPr id="80" name="Text 78"/>
-          <p:cNvSpPr/>
-          <p:nvPr/>
-        </p:nvSpPr>
-        <p:spPr>
-          <a:xfrm>
-            <a:off x="8796528" y="4562856"/>
-            <a:ext cx="3044952" cy="740664"/>
-          </a:xfrm>
-          <a:prstGeom prst="rect">
-            <a:avLst/>
-          </a:prstGeom>
-          <a:noFill/>
-          <a:ln/>
-        </p:spPr>
-        <p:txBody>
-          <a:bodyPr wrap="square" lIns="0" tIns="0" rIns="0" bIns="0" rtlCol="0" anchor="t"/>
-          <a:lstStyle/>
+            <a:r>
+              <a:rPr lang="en-US" sz="850" dirty="0">
+                <a:solidFill>
+                  <a:srgbClr val="A8BFDA"/>
+                </a:solidFill>
+              </a:rPr>
+              <a:t>.</a:t>
+            </a:r>
+          </a:p>
           <a:p>
             <a:pPr marL="0" indent="0">
               <a:lnSpc>
@@ -3621,15 +3524,7 @@
                   <a:srgbClr val="A8BFDA"/>
                 </a:solidFill>
               </a:rPr>
-              <a:t>Reviewing generated code to find problems to fix or enhancements </a:t>
-            </a:r>
-            <a:r>
-              <a:rPr lang="en-US" sz="850">
-                <a:solidFill>
-                  <a:srgbClr val="A8BFDA"/>
-                </a:solidFill>
-              </a:rPr>
-              <a:t>that can be done.</a:t>
+              <a:t>I learned new knowledge about AI.</a:t>
             </a:r>
             <a:endParaRPr lang="en-US" sz="850" dirty="0"/>
           </a:p>
@@ -3637,13 +3532,13 @@
       </p:sp>
       <p:sp>
         <p:nvSpPr>
-          <p:cNvPr id="81" name="Shape 79"/>
-          <p:cNvSpPr/>
-          <p:nvPr/>
-        </p:nvSpPr>
-        <p:spPr>
-          <a:xfrm>
-            <a:off x="8677656" y="5623560"/>
+          <p:cNvPr id="77" name="Shape 75"/>
+          <p:cNvSpPr/>
+          <p:nvPr/>
+        </p:nvSpPr>
+        <p:spPr>
+          <a:xfrm>
+            <a:off x="8677656" y="4160520"/>
             <a:ext cx="3182112" cy="0"/>
           </a:xfrm>
           <a:prstGeom prst="line">
@@ -3667,13 +3562,45 @@
       </p:sp>
       <p:sp>
         <p:nvSpPr>
-          <p:cNvPr id="82" name="Text 80"/>
-          <p:cNvSpPr/>
-          <p:nvPr/>
-        </p:nvSpPr>
-        <p:spPr>
-          <a:xfrm>
-            <a:off x="8796528" y="5742432"/>
+          <p:cNvPr id="78" name="Shape 76"/>
+          <p:cNvSpPr/>
+          <p:nvPr/>
+        </p:nvSpPr>
+        <p:spPr>
+          <a:xfrm>
+            <a:off x="8677656" y="4251960"/>
+            <a:ext cx="36576" cy="1143000"/>
+          </a:xfrm>
+          <a:prstGeom prst="rect">
+            <a:avLst/>
+          </a:prstGeom>
+          <a:solidFill>
+            <a:srgbClr val="00C8E0"/>
+          </a:solidFill>
+          <a:ln w="12700">
+            <a:solidFill>
+              <a:srgbClr val="00C8E0"/>
+            </a:solidFill>
+            <a:prstDash val="solid"/>
+          </a:ln>
+        </p:spPr>
+        <p:txBody>
+          <a:bodyPr/>
+          <a:lstStyle/>
+          <a:p>
+            <a:endParaRPr lang="en-US"/>
+          </a:p>
+        </p:txBody>
+      </p:sp>
+      <p:sp>
+        <p:nvSpPr>
+          <p:cNvPr id="79" name="Text 77"/>
+          <p:cNvSpPr/>
+          <p:nvPr/>
+        </p:nvSpPr>
+        <p:spPr>
+          <a:xfrm>
+            <a:off x="8796528" y="4343400"/>
             <a:ext cx="3044952" cy="201168"/>
           </a:xfrm>
           <a:prstGeom prst="rect">
@@ -3695,7 +3622,7 @@
                   <a:srgbClr val="4A6380"/>
                 </a:solidFill>
               </a:rPr>
-              <a:t>ADDITIONAL NOTES</a:t>
+              <a:t>NEXT STEPS</a:t>
             </a:r>
             <a:endParaRPr lang="en-US" sz="750" dirty="0"/>
           </a:p>
@@ -3703,14 +3630,14 @@
       </p:sp>
       <p:sp>
         <p:nvSpPr>
-          <p:cNvPr id="83" name="Text 81"/>
-          <p:cNvSpPr/>
-          <p:nvPr/>
-        </p:nvSpPr>
-        <p:spPr>
-          <a:xfrm>
-            <a:off x="8796528" y="5980176"/>
-            <a:ext cx="3044952" cy="914400"/>
+          <p:cNvPr id="80" name="Text 78"/>
+          <p:cNvSpPr/>
+          <p:nvPr/>
+        </p:nvSpPr>
+        <p:spPr>
+          <a:xfrm>
+            <a:off x="8796528" y="4562856"/>
+            <a:ext cx="3044952" cy="740664"/>
           </a:xfrm>
           <a:prstGeom prst="rect">
             <a:avLst/>
@@ -3731,10 +3658,114 @@
             <a:r>
               <a:rPr lang="en-US" sz="850" dirty="0">
                 <a:solidFill>
+                  <a:srgbClr val="A8BFDA"/>
+                </a:solidFill>
+              </a:rPr>
+              <a:t>Reviewing generated code to find problems to fix or enhancements that can be done.</a:t>
+            </a:r>
+            <a:endParaRPr lang="en-US" sz="850" dirty="0"/>
+          </a:p>
+        </p:txBody>
+      </p:sp>
+      <p:sp>
+        <p:nvSpPr>
+          <p:cNvPr id="81" name="Shape 79"/>
+          <p:cNvSpPr/>
+          <p:nvPr/>
+        </p:nvSpPr>
+        <p:spPr>
+          <a:xfrm>
+            <a:off x="8677656" y="5623560"/>
+            <a:ext cx="3182112" cy="0"/>
+          </a:xfrm>
+          <a:prstGeom prst="line">
+            <a:avLst/>
+          </a:prstGeom>
+          <a:noFill/>
+          <a:ln w="5080">
+            <a:solidFill>
+              <a:srgbClr val="132238"/>
+            </a:solidFill>
+            <a:prstDash val="solid"/>
+          </a:ln>
+        </p:spPr>
+        <p:txBody>
+          <a:bodyPr/>
+          <a:lstStyle/>
+          <a:p>
+            <a:endParaRPr lang="en-US"/>
+          </a:p>
+        </p:txBody>
+      </p:sp>
+      <p:sp>
+        <p:nvSpPr>
+          <p:cNvPr id="82" name="Text 80"/>
+          <p:cNvSpPr/>
+          <p:nvPr/>
+        </p:nvSpPr>
+        <p:spPr>
+          <a:xfrm>
+            <a:off x="8796528" y="5742432"/>
+            <a:ext cx="3044952" cy="201168"/>
+          </a:xfrm>
+          <a:prstGeom prst="rect">
+            <a:avLst/>
+          </a:prstGeom>
+          <a:noFill/>
+          <a:ln/>
+        </p:spPr>
+        <p:txBody>
+          <a:bodyPr wrap="square" lIns="0" tIns="0" rIns="0" bIns="0" rtlCol="0" anchor="ctr"/>
+          <a:lstStyle/>
+          <a:p>
+            <a:pPr marL="0" indent="0">
+              <a:buNone/>
+            </a:pPr>
+            <a:r>
+              <a:rPr lang="en-US" sz="750" b="1" kern="0" spc="200" dirty="0">
+                <a:solidFill>
                   <a:srgbClr val="4A6380"/>
                 </a:solidFill>
               </a:rPr>
-              <a:t>Any links, resources, or context relevant to the project.</a:t>
+              <a:t>ADDITIONAL NOTES</a:t>
+            </a:r>
+            <a:endParaRPr lang="en-US" sz="750" dirty="0"/>
+          </a:p>
+        </p:txBody>
+      </p:sp>
+      <p:sp>
+        <p:nvSpPr>
+          <p:cNvPr id="83" name="Text 81"/>
+          <p:cNvSpPr/>
+          <p:nvPr/>
+        </p:nvSpPr>
+        <p:spPr>
+          <a:xfrm>
+            <a:off x="8796528" y="5980176"/>
+            <a:ext cx="3044952" cy="521207"/>
+          </a:xfrm>
+          <a:prstGeom prst="rect">
+            <a:avLst/>
+          </a:prstGeom>
+          <a:noFill/>
+          <a:ln/>
+        </p:spPr>
+        <p:txBody>
+          <a:bodyPr wrap="square" lIns="0" tIns="0" rIns="0" bIns="0" rtlCol="0" anchor="t"/>
+          <a:lstStyle/>
+          <a:p>
+            <a:pPr>
+              <a:lnSpc>
+                <a:spcPct val="140000"/>
+              </a:lnSpc>
+            </a:pPr>
+            <a:r>
+              <a:rPr lang="en-US" sz="850" dirty="0">
+                <a:solidFill>
+                  <a:srgbClr val="4A6380"/>
+                </a:solidFill>
+              </a:rPr>
+              <a:t>https://www.npmjs.com/package/@codemieai/code</a:t>
             </a:r>
             <a:endParaRPr lang="en-US" sz="850" dirty="0"/>
           </a:p>

</xml_diff>